<commit_message>
docs: consolidate VIA presentation into one editable deck
Refresh the overview, requirements, scenario notes and DP QA for the current
41/44/45/42 scope, six ASR goals and separate voice and semantic models.
Preserve the old presentations as history and combine the seven current inputs
into a 32-slide canonical deck with notes, editable objects, GIFs and sections.
Add keyed slide replacement and document the single-deck editing workflow.

Correct the P21 ordinary reaction guard to 100/105 alongside the 30 burst
trials; derive these counts from the population and archive the previous files.

Presentation, QA, link, terminology and catalog checks pass. Full CI checks
pass 20/23; the 42/44/45 diagram drift failures also occur on untouched
2ed646f14 and those diagrams/generators are outside this change.
</commit_message>
<xml_diff>
--- a/docs/presentations_files/VIA-representative-scenario.pptx
+++ b/docs/presentations_files/VIA-representative-scenario.pptx
@@ -2,13 +2,13 @@
 <file path=ppt/presentation.xml><?xml version="1.0" encoding="utf-8"?>
 <p:presentation xmlns:p="http://schemas.openxmlformats.org/presentationml/2006/main">
   <p:sldMasterIdLst>
-    <p:sldMasterId xmlns:r="http://schemas.openxmlformats.org/officeDocument/2006/relationships" id="2147483648" r:id="R9fabd659c97842f4"/>
+    <p:sldMasterId xmlns:r="http://schemas.openxmlformats.org/officeDocument/2006/relationships" id="2147483648" r:id="R93b2c4e90ed24369"/>
   </p:sldMasterIdLst>
   <p:notesMasterIdLst>
-    <p:notesMasterId xmlns:r="http://schemas.openxmlformats.org/officeDocument/2006/relationships" r:id="Ra071fa44f198401c"/>
+    <p:notesMasterId xmlns:r="http://schemas.openxmlformats.org/officeDocument/2006/relationships" r:id="Rf36309cb168545cb"/>
   </p:notesMasterIdLst>
   <p:sldIdLst>
-    <p:sldId xmlns:r="http://schemas.openxmlformats.org/officeDocument/2006/relationships" id="256" r:id="R3feacd938cfb48f0"/>
+    <p:sldId xmlns:r="http://schemas.openxmlformats.org/officeDocument/2006/relationships" id="256" r:id="Rddefe33400514981"/>
   </p:sldIdLst>
   <p:sldSz cx="12192000" cy="6858000"/>
   <p:notesSz cx="6858000" cy="9144000"/>
@@ -482,7 +482,7 @@
           </a:p>
           <a:p xmlns:a="http://schemas.openxmlformats.org/drawingml/2006/main">
             <a:r>
-              <a:t>원문: docs/architecture/05-representative-use-cases.md, docs/architecture/03-fixed-architecture-scope.md, docs/architecture/12-decisions/decision-packages/04-41-request-resolution-control.md, 04-42-lifecycle-ownership.md, 04-43-request-interpretation.md, 04-44-continuous-interaction.md, 04-45-memory-and-context.md. 상세 연결은 docs/presentations_files/representative-scenario/README.md에 기록한다.</a:t>
+              <a:t>원문: docs/architecture/05-representative-use-cases.md, docs/architecture/03-fixed-architecture-scope.md, docs/architecture/12-decisions/decision-packages/04-40-common-execution-contract.md, 04-41-request-resolution-control.md, 04-42-lifecycle-ownership.md, 04-44-continuous-interaction.md, 04-45-memory-and-context.md. 품질 원본: 03-02-quality-attribute-definitions.md (ASR-QA-v6). 상세 연결은 docs/presentations_files/representative-scenario/README.md에 기록한다.</a:t>
             </a:r>
           </a:p>
           <a:p xmlns:a="http://schemas.openxmlformats.org/drawingml/2006/main">
@@ -502,7 +502,27 @@
           </a:p>
           <a:p xmlns:a="http://schemas.openxmlformats.org/drawingml/2006/main">
             <a:r>
-              <a:t>V04는 평균 반응시간, V05는 평균 VIA 처리시간이다. 이 대표 시나리오는 기능과 설계 논점을 보여주는 발표 예시이며, 측정 결과나 대안 우열을 주장하지 않는다.</a:t>
+              <a:t>품질 연결은 ASR-QA-01 요청 처리 정확성, 02 상호작용 응답시간, 03 VIA 요청 처리시간을 중심으로 설명한다. 공통 P21은 21개 사례 전체를 5회 수행해 630조건, 135반응, 95처리를 관측한다. 이 다섯 장면은 P21의 원천 입력과 동일한 fixture가 아니며 사례 대응은 기능상 유사성이다. QA-04 모델 비용과 QA-06 로컬 메모리는 준비, 재사용, 갱신, 폐기와 tail을 포함한 전체 활동에서 평가한다. QA-05 변경 용이성은 별도 M-01~06 변경 과제로 평가한다. 평균과 보호 조건은 품질 원본을 따른다. 아직 후보 실측과 대안 선정은 없다.</a:t>
+            </a:r>
+          </a:p>
+          <a:p xmlns:a="http://schemas.openxmlformats.org/drawingml/2006/main">
+            <a:r>
+              <a:t/>
+            </a:r>
+          </a:p>
+          <a:p xmlns:a="http://schemas.openxmlformats.org/drawingml/2006/main">
+            <a:r>
+              <a:t>장면 대응: ① 표 지칭은 S2-01과 제한 조회 S1-01의 유사 경로, ② 독립 업무는 S3-01과 과거 설명 재사용 S2-02의 유사 경로, ③ 부분 정정은 S4-01, local stop는 S4-02, 과거 근거는 S2-02/04/05, ④ 질문 전달/답변은 S5-01/S5-04/S6-04, ⑤ Voice 종료 후 Text 전달은 S5-03 및 UC-15의 정상 채널 전환이다. 41은 의미와 관계, 44는 실행 연결과 반응, 45는 과거 근거, 42는 업무 및 질문 상태의 수명을 비교한다.</a:t>
+            </a:r>
+          </a:p>
+          <a:p xmlns:a="http://schemas.openxmlformats.org/drawingml/2006/main">
+            <a:r>
+              <a:t/>
+            </a:r>
+          </a:p>
+          <a:p xmlns:a="http://schemas.openxmlformats.org/drawingml/2006/main">
+            <a:r>
+              <a:t>모델 배치는 로컬 VIA 및 로컬 VAD, 별도 클라우드 음성 모델과 의미 LLM이다. 모델 서비스의 임시 session과 VIA의 영속 Request/Task/실제 전달 원장을 구별한다. 모델 선정이나 제품 구현 완료를 뜻하지 않는다.</a:t>
             </a:r>
           </a:p>
         </p:txBody>
@@ -570,7 +590,7 @@
   </p:cSld>
   <p:clrMap bg1="lt1" tx1="dk1" bg2="lt2" tx2="dk2" accent1="accent1" accent2="accent2" accent3="accent3" accent4="accent4" accent5="accent5" accent6="accent6" hlink="hlink" folHlink="folHlink"/>
   <p:sldLayoutIdLst>
-    <p:sldLayoutId xmlns:r="http://schemas.openxmlformats.org/officeDocument/2006/relationships" id="2147483649" r:id="R57b8a08c09274171"/>
+    <p:sldLayoutId xmlns:r="http://schemas.openxmlformats.org/officeDocument/2006/relationships" id="2147483649" r:id="R791a9a63be60469d"/>
   </p:sldLayoutIdLst>
   <p:txStyles>
     <p:titleStyle>
@@ -1121,7 +1141,7 @@
           <p:cNvPr id="37" name="title">
             <a:extLst xmlns:a="http://schemas.openxmlformats.org/drawingml/2006/main">
               <a:ext uri="{FF2B5EF4-FFF2-40B4-BE49-F238E27FC236}">
-                <a16:creationId xmlns:a16="http://schemas.microsoft.com/office/drawing/2014/main" id="{67A7F7CD-5B62-4B1C-838B-49C35F156F1B}"/>
+                <a16:creationId xmlns:a16="http://schemas.microsoft.com/office/drawing/2014/main" id="{46F7D485-C964-46E9-A0CE-CDC23268F0C7}"/>
               </a:ext>
             </a:extLst>
           </p:cNvPr>
@@ -1178,7 +1198,7 @@
           <p:cNvPr id="2" name="section-0">
             <a:extLst xmlns:a="http://schemas.openxmlformats.org/drawingml/2006/main">
               <a:ext uri="{FF2B5EF4-FFF2-40B4-BE49-F238E27FC236}">
-                <a16:creationId xmlns:a16="http://schemas.microsoft.com/office/drawing/2014/main" id="{6F0F70E5-4D3A-4ADA-888A-7D93A134F242}"/>
+                <a16:creationId xmlns:a16="http://schemas.microsoft.com/office/drawing/2014/main" id="{20627BC3-C17E-4ECB-8D90-84B3CDD85147}"/>
               </a:ext>
             </a:extLst>
           </p:cNvPr>
@@ -1210,7 +1230,7 @@
           <p:cNvPr id="3" name="section-label-0">
             <a:extLst xmlns:a="http://schemas.openxmlformats.org/drawingml/2006/main">
               <a:ext uri="{FF2B5EF4-FFF2-40B4-BE49-F238E27FC236}">
-                <a16:creationId xmlns:a16="http://schemas.microsoft.com/office/drawing/2014/main" id="{06A3F4B9-D906-4B6C-B403-174861639C92}"/>
+                <a16:creationId xmlns:a16="http://schemas.microsoft.com/office/drawing/2014/main" id="{594294E0-16A6-4BF9-84BC-3A17ABB9236F}"/>
               </a:ext>
             </a:extLst>
           </p:cNvPr>
@@ -1267,7 +1287,7 @@
           <p:cNvPr id="4" name="section-1">
             <a:extLst xmlns:a="http://schemas.openxmlformats.org/drawingml/2006/main">
               <a:ext uri="{FF2B5EF4-FFF2-40B4-BE49-F238E27FC236}">
-                <a16:creationId xmlns:a16="http://schemas.microsoft.com/office/drawing/2014/main" id="{5839236F-B642-4C77-830E-3913305F1F2C}"/>
+                <a16:creationId xmlns:a16="http://schemas.microsoft.com/office/drawing/2014/main" id="{97AB402B-EC30-4A94-87A4-96FBB07F024A}"/>
               </a:ext>
             </a:extLst>
           </p:cNvPr>
@@ -1299,7 +1319,7 @@
           <p:cNvPr id="5" name="section-label-1">
             <a:extLst xmlns:a="http://schemas.openxmlformats.org/drawingml/2006/main">
               <a:ext uri="{FF2B5EF4-FFF2-40B4-BE49-F238E27FC236}">
-                <a16:creationId xmlns:a16="http://schemas.microsoft.com/office/drawing/2014/main" id="{8E527347-9D0B-43DC-BCDB-222F7CBF06D7}"/>
+                <a16:creationId xmlns:a16="http://schemas.microsoft.com/office/drawing/2014/main" id="{F8B2CBA6-5C2F-48E7-A45B-F7F4937EAD27}"/>
               </a:ext>
             </a:extLst>
           </p:cNvPr>
@@ -1356,7 +1376,7 @@
           <p:cNvPr id="6" name="section-2">
             <a:extLst xmlns:a="http://schemas.openxmlformats.org/drawingml/2006/main">
               <a:ext uri="{FF2B5EF4-FFF2-40B4-BE49-F238E27FC236}">
-                <a16:creationId xmlns:a16="http://schemas.microsoft.com/office/drawing/2014/main" id="{6B03EF58-75F9-453D-9EB5-2E0ADDE1382B}"/>
+                <a16:creationId xmlns:a16="http://schemas.microsoft.com/office/drawing/2014/main" id="{5D16BE09-CF50-44BB-BEFD-FBDA196F12C4}"/>
               </a:ext>
             </a:extLst>
           </p:cNvPr>
@@ -1388,7 +1408,7 @@
           <p:cNvPr id="7" name="section-label-2">
             <a:extLst xmlns:a="http://schemas.openxmlformats.org/drawingml/2006/main">
               <a:ext uri="{FF2B5EF4-FFF2-40B4-BE49-F238E27FC236}">
-                <a16:creationId xmlns:a16="http://schemas.microsoft.com/office/drawing/2014/main" id="{8E6B22D1-E159-40F9-B44B-C23D73C45C7C}"/>
+                <a16:creationId xmlns:a16="http://schemas.microsoft.com/office/drawing/2014/main" id="{D842BAC8-B832-47D2-8D12-6BDD33D3CC9D}"/>
               </a:ext>
             </a:extLst>
           </p:cNvPr>
@@ -1445,7 +1465,7 @@
           <p:cNvPr id="8" name="section-3">
             <a:extLst xmlns:a="http://schemas.openxmlformats.org/drawingml/2006/main">
               <a:ext uri="{FF2B5EF4-FFF2-40B4-BE49-F238E27FC236}">
-                <a16:creationId xmlns:a16="http://schemas.microsoft.com/office/drawing/2014/main" id="{CAEC9189-07B6-4407-B61C-5A4253737DA3}"/>
+                <a16:creationId xmlns:a16="http://schemas.microsoft.com/office/drawing/2014/main" id="{B6F9D7ED-363F-4286-BDD4-67556B86292D}"/>
               </a:ext>
             </a:extLst>
           </p:cNvPr>
@@ -1477,7 +1497,7 @@
           <p:cNvPr id="9" name="section-label-3">
             <a:extLst xmlns:a="http://schemas.openxmlformats.org/drawingml/2006/main">
               <a:ext uri="{FF2B5EF4-FFF2-40B4-BE49-F238E27FC236}">
-                <a16:creationId xmlns:a16="http://schemas.microsoft.com/office/drawing/2014/main" id="{323727C9-9E53-4F27-951E-80F9249A35D9}"/>
+                <a16:creationId xmlns:a16="http://schemas.microsoft.com/office/drawing/2014/main" id="{B467D0E6-2704-4D2E-8C2C-E5592A943B84}"/>
               </a:ext>
             </a:extLst>
           </p:cNvPr>
@@ -1534,7 +1554,7 @@
           <p:cNvPr id="10" name="section-4">
             <a:extLst xmlns:a="http://schemas.openxmlformats.org/drawingml/2006/main">
               <a:ext uri="{FF2B5EF4-FFF2-40B4-BE49-F238E27FC236}">
-                <a16:creationId xmlns:a16="http://schemas.microsoft.com/office/drawing/2014/main" id="{71B118AF-B2FC-461D-A075-F8D11174570B}"/>
+                <a16:creationId xmlns:a16="http://schemas.microsoft.com/office/drawing/2014/main" id="{DF6231EB-4064-404D-AC37-EE49327DC1EE}"/>
               </a:ext>
             </a:extLst>
           </p:cNvPr>
@@ -1566,7 +1586,7 @@
           <p:cNvPr id="11" name="section-label-4">
             <a:extLst xmlns:a="http://schemas.openxmlformats.org/drawingml/2006/main">
               <a:ext uri="{FF2B5EF4-FFF2-40B4-BE49-F238E27FC236}">
-                <a16:creationId xmlns:a16="http://schemas.microsoft.com/office/drawing/2014/main" id="{9D3C965A-191E-4829-B82C-E1EFB05E8BF0}"/>
+                <a16:creationId xmlns:a16="http://schemas.microsoft.com/office/drawing/2014/main" id="{796213A6-DC64-4F3D-9652-57DC33BFCF91}"/>
               </a:ext>
             </a:extLst>
           </p:cNvPr>
@@ -1623,7 +1643,7 @@
           <p:cNvPr id="12" name="header-rule">
             <a:extLst xmlns:a="http://schemas.openxmlformats.org/drawingml/2006/main">
               <a:ext uri="{FF2B5EF4-FFF2-40B4-BE49-F238E27FC236}">
-                <a16:creationId xmlns:a16="http://schemas.microsoft.com/office/drawing/2014/main" id="{6F6A9C59-838A-4C71-8EAA-9BCD28FB6482}"/>
+                <a16:creationId xmlns:a16="http://schemas.microsoft.com/office/drawing/2014/main" id="{B2FFB637-6F21-40C6-93AB-2459860B94D3}"/>
               </a:ext>
             </a:extLst>
           </p:cNvPr>
@@ -1653,7 +1673,7 @@
           <p:cNvPr id="13" name="story-subtitle">
             <a:extLst xmlns:a="http://schemas.openxmlformats.org/drawingml/2006/main">
               <a:ext uri="{FF2B5EF4-FFF2-40B4-BE49-F238E27FC236}">
-                <a16:creationId xmlns:a16="http://schemas.microsoft.com/office/drawing/2014/main" id="{5F1684A6-FB22-46EF-9413-52FF602F6AB7}"/>
+                <a16:creationId xmlns:a16="http://schemas.microsoft.com/office/drawing/2014/main" id="{47F356DB-9521-48F7-85C3-C5F3CD458536}"/>
               </a:ext>
             </a:extLst>
           </p:cNvPr>
@@ -1710,7 +1730,7 @@
           <p:cNvPr id="14" name="scene-1-heading">
             <a:extLst xmlns:a="http://schemas.openxmlformats.org/drawingml/2006/main">
               <a:ext uri="{FF2B5EF4-FFF2-40B4-BE49-F238E27FC236}">
-                <a16:creationId xmlns:a16="http://schemas.microsoft.com/office/drawing/2014/main" id="{E55D0328-CD90-4025-B5C6-511D3A9EA23D}"/>
+                <a16:creationId xmlns:a16="http://schemas.microsoft.com/office/drawing/2014/main" id="{C5511969-CEC3-491E-AB61-000EC3136B73}"/>
               </a:ext>
             </a:extLst>
           </p:cNvPr>
@@ -1771,7 +1791,7 @@
           <p:nvPr/>
         </p:nvPicPr>
         <p:blipFill>
-          <a:blip xmlns:r="http://schemas.openxmlformats.org/officeDocument/2006/relationships" xmlns:a="http://schemas.openxmlformats.org/drawingml/2006/main" r:embed="Ra5b14305f14b4083"/>
+          <a:blip xmlns:r="http://schemas.openxmlformats.org/officeDocument/2006/relationships" xmlns:a="http://schemas.openxmlformats.org/drawingml/2006/main" r:embed="R412e7293f74449f5"/>
           <a:stretch xmlns:a="http://schemas.openxmlformats.org/drawingml/2006/main"/>
         </p:blipFill>
         <p:spPr>
@@ -1789,7 +1809,7 @@
           <p:cNvPr id="16" name="scene-1-quote">
             <a:extLst xmlns:a="http://schemas.openxmlformats.org/drawingml/2006/main">
               <a:ext uri="{FF2B5EF4-FFF2-40B4-BE49-F238E27FC236}">
-                <a16:creationId xmlns:a16="http://schemas.microsoft.com/office/drawing/2014/main" id="{388498BD-A2B4-46BA-B08E-5305A0AFDB72}"/>
+                <a16:creationId xmlns:a16="http://schemas.microsoft.com/office/drawing/2014/main" id="{691EB006-7091-4E58-A0DB-372F04BD0BE7}"/>
               </a:ext>
             </a:extLst>
           </p:cNvPr>
@@ -1869,7 +1889,7 @@
           <p:cNvPr id="17" name="scene-1-behavior">
             <a:extLst xmlns:a="http://schemas.openxmlformats.org/drawingml/2006/main">
               <a:ext uri="{FF2B5EF4-FFF2-40B4-BE49-F238E27FC236}">
-                <a16:creationId xmlns:a16="http://schemas.microsoft.com/office/drawing/2014/main" id="{703C3EA7-E129-407E-83CE-B4E4B53FF2EE}"/>
+                <a16:creationId xmlns:a16="http://schemas.microsoft.com/office/drawing/2014/main" id="{D24BD105-AA78-44A0-83C1-FE0B8B4F10B1}"/>
               </a:ext>
             </a:extLst>
           </p:cNvPr>
@@ -1949,7 +1969,7 @@
           <p:cNvPr id="18" name="scene-2-heading">
             <a:extLst xmlns:a="http://schemas.openxmlformats.org/drawingml/2006/main">
               <a:ext uri="{FF2B5EF4-FFF2-40B4-BE49-F238E27FC236}">
-                <a16:creationId xmlns:a16="http://schemas.microsoft.com/office/drawing/2014/main" id="{5C20E42F-B1D7-4536-88F9-10E78CF9AFC9}"/>
+                <a16:creationId xmlns:a16="http://schemas.microsoft.com/office/drawing/2014/main" id="{F444B45D-43D8-4C1A-8A6A-75510E1BFE21}"/>
               </a:ext>
             </a:extLst>
           </p:cNvPr>
@@ -2010,7 +2030,7 @@
           <p:nvPr/>
         </p:nvPicPr>
         <p:blipFill>
-          <a:blip xmlns:r="http://schemas.openxmlformats.org/officeDocument/2006/relationships" xmlns:a="http://schemas.openxmlformats.org/drawingml/2006/main" r:embed="R50fd83f6dad24aaf"/>
+          <a:blip xmlns:r="http://schemas.openxmlformats.org/officeDocument/2006/relationships" xmlns:a="http://schemas.openxmlformats.org/drawingml/2006/main" r:embed="R7d0fe689e32e4185"/>
           <a:stretch xmlns:a="http://schemas.openxmlformats.org/drawingml/2006/main"/>
         </p:blipFill>
         <p:spPr>
@@ -2028,7 +2048,7 @@
           <p:cNvPr id="20" name="scene-2-quote">
             <a:extLst xmlns:a="http://schemas.openxmlformats.org/drawingml/2006/main">
               <a:ext uri="{FF2B5EF4-FFF2-40B4-BE49-F238E27FC236}">
-                <a16:creationId xmlns:a16="http://schemas.microsoft.com/office/drawing/2014/main" id="{A1FF0C75-6E89-4B52-B440-99DD00E635F4}"/>
+                <a16:creationId xmlns:a16="http://schemas.microsoft.com/office/drawing/2014/main" id="{5C2FC624-B809-4890-B7CF-A40661BCF06A}"/>
               </a:ext>
             </a:extLst>
           </p:cNvPr>
@@ -2154,7 +2174,7 @@
           <p:cNvPr id="21" name="scene-2-behavior">
             <a:extLst xmlns:a="http://schemas.openxmlformats.org/drawingml/2006/main">
               <a:ext uri="{FF2B5EF4-FFF2-40B4-BE49-F238E27FC236}">
-                <a16:creationId xmlns:a16="http://schemas.microsoft.com/office/drawing/2014/main" id="{C890FF79-D912-4567-8130-B7EB0CD46071}"/>
+                <a16:creationId xmlns:a16="http://schemas.microsoft.com/office/drawing/2014/main" id="{B49DEA0C-5527-4A70-B806-7F62CFCE5A8F}"/>
               </a:ext>
             </a:extLst>
           </p:cNvPr>
@@ -2234,7 +2254,7 @@
           <p:cNvPr id="22" name="scene-3-heading">
             <a:extLst xmlns:a="http://schemas.openxmlformats.org/drawingml/2006/main">
               <a:ext uri="{FF2B5EF4-FFF2-40B4-BE49-F238E27FC236}">
-                <a16:creationId xmlns:a16="http://schemas.microsoft.com/office/drawing/2014/main" id="{D59A0FC2-115A-44EE-8474-5D15B362BF33}"/>
+                <a16:creationId xmlns:a16="http://schemas.microsoft.com/office/drawing/2014/main" id="{5955D440-3682-4EF4-BF97-B254C94F2564}"/>
               </a:ext>
             </a:extLst>
           </p:cNvPr>
@@ -2295,7 +2315,7 @@
           <p:nvPr/>
         </p:nvPicPr>
         <p:blipFill>
-          <a:blip xmlns:r="http://schemas.openxmlformats.org/officeDocument/2006/relationships" xmlns:a="http://schemas.openxmlformats.org/drawingml/2006/main" r:embed="R14d836b58f1f4f9d"/>
+          <a:blip xmlns:r="http://schemas.openxmlformats.org/officeDocument/2006/relationships" xmlns:a="http://schemas.openxmlformats.org/drawingml/2006/main" r:embed="Rdc14f194c893430b"/>
           <a:stretch xmlns:a="http://schemas.openxmlformats.org/drawingml/2006/main"/>
         </p:blipFill>
         <p:spPr>
@@ -2313,7 +2333,7 @@
           <p:cNvPr id="24" name="scene-3-quote">
             <a:extLst xmlns:a="http://schemas.openxmlformats.org/drawingml/2006/main">
               <a:ext uri="{FF2B5EF4-FFF2-40B4-BE49-F238E27FC236}">
-                <a16:creationId xmlns:a16="http://schemas.microsoft.com/office/drawing/2014/main" id="{E9CFC49A-0B52-4547-9D1D-8F0C7D7AAA91}"/>
+                <a16:creationId xmlns:a16="http://schemas.microsoft.com/office/drawing/2014/main" id="{CCE8EA90-40AF-42D8-8483-731D01F7CDF7}"/>
               </a:ext>
             </a:extLst>
           </p:cNvPr>
@@ -2416,7 +2436,7 @@
           <p:cNvPr id="25" name="scene-3-behavior">
             <a:extLst xmlns:a="http://schemas.openxmlformats.org/drawingml/2006/main">
               <a:ext uri="{FF2B5EF4-FFF2-40B4-BE49-F238E27FC236}">
-                <a16:creationId xmlns:a16="http://schemas.microsoft.com/office/drawing/2014/main" id="{61EE5EE6-FD9B-48F1-9CA4-CF5F5769B10C}"/>
+                <a16:creationId xmlns:a16="http://schemas.microsoft.com/office/drawing/2014/main" id="{CCA6DEBB-4F56-42DC-AD0B-4607FC971EBD}"/>
               </a:ext>
             </a:extLst>
           </p:cNvPr>
@@ -2496,7 +2516,7 @@
           <p:cNvPr id="26" name="scene-4-heading">
             <a:extLst xmlns:a="http://schemas.openxmlformats.org/drawingml/2006/main">
               <a:ext uri="{FF2B5EF4-FFF2-40B4-BE49-F238E27FC236}">
-                <a16:creationId xmlns:a16="http://schemas.microsoft.com/office/drawing/2014/main" id="{0667582C-DC61-4CAE-9267-18BDD9454DCA}"/>
+                <a16:creationId xmlns:a16="http://schemas.microsoft.com/office/drawing/2014/main" id="{9DB00A0E-71FC-453F-80B7-2DD7772B4A75}"/>
               </a:ext>
             </a:extLst>
           </p:cNvPr>
@@ -2557,7 +2577,7 @@
           <p:nvPr/>
         </p:nvPicPr>
         <p:blipFill>
-          <a:blip xmlns:r="http://schemas.openxmlformats.org/officeDocument/2006/relationships" xmlns:a="http://schemas.openxmlformats.org/drawingml/2006/main" r:embed="Rb350e252d968465d"/>
+          <a:blip xmlns:r="http://schemas.openxmlformats.org/officeDocument/2006/relationships" xmlns:a="http://schemas.openxmlformats.org/drawingml/2006/main" r:embed="R926c21a837c1492e"/>
           <a:stretch xmlns:a="http://schemas.openxmlformats.org/drawingml/2006/main"/>
         </p:blipFill>
         <p:spPr>
@@ -2575,7 +2595,7 @@
           <p:cNvPr id="28" name="scene-4-quote">
             <a:extLst xmlns:a="http://schemas.openxmlformats.org/drawingml/2006/main">
               <a:ext uri="{FF2B5EF4-FFF2-40B4-BE49-F238E27FC236}">
-                <a16:creationId xmlns:a16="http://schemas.microsoft.com/office/drawing/2014/main" id="{0D37A773-2587-4554-AFB2-77CD12101339}"/>
+                <a16:creationId xmlns:a16="http://schemas.microsoft.com/office/drawing/2014/main" id="{4D94570C-5467-41D6-8C6E-E2AAAF0ADD90}"/>
               </a:ext>
             </a:extLst>
           </p:cNvPr>
@@ -2678,7 +2698,7 @@
           <p:cNvPr id="29" name="scene-4-behavior">
             <a:extLst xmlns:a="http://schemas.openxmlformats.org/drawingml/2006/main">
               <a:ext uri="{FF2B5EF4-FFF2-40B4-BE49-F238E27FC236}">
-                <a16:creationId xmlns:a16="http://schemas.microsoft.com/office/drawing/2014/main" id="{B2CCB08A-F48E-4D84-BD72-F566922B86BE}"/>
+                <a16:creationId xmlns:a16="http://schemas.microsoft.com/office/drawing/2014/main" id="{35249B1C-946B-40EB-964E-37DBC59AE3A6}"/>
               </a:ext>
             </a:extLst>
           </p:cNvPr>
@@ -2758,7 +2778,7 @@
           <p:cNvPr id="30" name="scene-5-heading">
             <a:extLst xmlns:a="http://schemas.openxmlformats.org/drawingml/2006/main">
               <a:ext uri="{FF2B5EF4-FFF2-40B4-BE49-F238E27FC236}">
-                <a16:creationId xmlns:a16="http://schemas.microsoft.com/office/drawing/2014/main" id="{D5D5D5FC-3A1C-4688-9839-BC2FCA732BC7}"/>
+                <a16:creationId xmlns:a16="http://schemas.microsoft.com/office/drawing/2014/main" id="{D2E74A05-3BE2-41CD-A790-11D160FBE758}"/>
               </a:ext>
             </a:extLst>
           </p:cNvPr>
@@ -2819,7 +2839,7 @@
           <p:nvPr/>
         </p:nvPicPr>
         <p:blipFill>
-          <a:blip xmlns:r="http://schemas.openxmlformats.org/officeDocument/2006/relationships" xmlns:a="http://schemas.openxmlformats.org/drawingml/2006/main" r:embed="R5984375ce34b4136"/>
+          <a:blip xmlns:r="http://schemas.openxmlformats.org/officeDocument/2006/relationships" xmlns:a="http://schemas.openxmlformats.org/drawingml/2006/main" r:embed="Re7e7daa896bb48e9"/>
           <a:stretch xmlns:a="http://schemas.openxmlformats.org/drawingml/2006/main"/>
         </p:blipFill>
         <p:spPr>
@@ -2837,7 +2857,7 @@
           <p:cNvPr id="32" name="scene-5-quote">
             <a:extLst xmlns:a="http://schemas.openxmlformats.org/drawingml/2006/main">
               <a:ext uri="{FF2B5EF4-FFF2-40B4-BE49-F238E27FC236}">
-                <a16:creationId xmlns:a16="http://schemas.microsoft.com/office/drawing/2014/main" id="{6BF40EC9-66EE-4EC1-8B4A-0886F0FEF8DF}"/>
+                <a16:creationId xmlns:a16="http://schemas.microsoft.com/office/drawing/2014/main" id="{893A4672-D5DF-455D-940A-8A6C3023211E}"/>
               </a:ext>
             </a:extLst>
           </p:cNvPr>
@@ -2917,7 +2937,7 @@
           <p:cNvPr id="33" name="scene-5-behavior">
             <a:extLst xmlns:a="http://schemas.openxmlformats.org/drawingml/2006/main">
               <a:ext uri="{FF2B5EF4-FFF2-40B4-BE49-F238E27FC236}">
-                <a16:creationId xmlns:a16="http://schemas.microsoft.com/office/drawing/2014/main" id="{17432BF4-4EE2-4BEC-981A-C2BFE17227E4}"/>
+                <a16:creationId xmlns:a16="http://schemas.microsoft.com/office/drawing/2014/main" id="{58D903F9-C2B1-4D00-91ED-95DE64352D92}"/>
               </a:ext>
             </a:extLst>
           </p:cNvPr>
@@ -3403,7 +3423,7 @@
           <p:cNvPr id="35" name="role-boundary">
             <a:extLst xmlns:a="http://schemas.openxmlformats.org/drawingml/2006/main">
               <a:ext uri="{FF2B5EF4-FFF2-40B4-BE49-F238E27FC236}">
-                <a16:creationId xmlns:a16="http://schemas.microsoft.com/office/drawing/2014/main" id="{1F3EDD32-959C-4C94-9D04-00F21A817203}"/>
+                <a16:creationId xmlns:a16="http://schemas.microsoft.com/office/drawing/2014/main" id="{18F976E7-BC2C-4ABE-97FC-1718E9E62D45}"/>
               </a:ext>
             </a:extLst>
           </p:cNvPr>
@@ -3460,7 +3480,7 @@
           <p:cNvPr id="36" name="page-number">
             <a:extLst xmlns:a="http://schemas.openxmlformats.org/drawingml/2006/main">
               <a:ext uri="{FF2B5EF4-FFF2-40B4-BE49-F238E27FC236}">
-                <a16:creationId xmlns:a16="http://schemas.microsoft.com/office/drawing/2014/main" id="{1CC5A8D8-4E2F-49BC-B534-92450973C44C}"/>
+                <a16:creationId xmlns:a16="http://schemas.microsoft.com/office/drawing/2014/main" id="{0247B05C-8071-4B4A-91A2-F4EFB8862C21}"/>
               </a:ext>
             </a:extLst>
           </p:cNvPr>
@@ -3515,7 +3535,7 @@
     </p:spTree>
     <p:extLst>
       <p:ext uri="{BB962C8B-B14F-4D97-AF65-F5344CB8AC3E}">
-        <p14:creationId xmlns:p14="http://schemas.microsoft.com/office/powerpoint/2010/main" val="428739133"/>
+        <p14:creationId xmlns:p14="http://schemas.microsoft.com/office/powerpoint/2010/main" val="679796911"/>
       </p:ext>
     </p:extLst>
   </p:cSld>

</xml_diff>